<commit_message>
Add Live Deployment slide to presentation
New slide 16 shows the real, verified-live URLs (Netlify, Render
backend/AI, GitHub) and the end-to-end production test result, ahead
of the Roadmap & Conclusion slide.

Co-Authored-By: Claude Sonnet 5 <noreply@anthropic.com>
</commit_message>
<xml_diff>
--- a/presentation/Nellai_Green_Civic.pptx
+++ b/presentation/Nellai_Green_Civic.pptx
@@ -21,9 +21,10 @@
     <p:sldId id="269" r:id="rId15"/>
     <p:sldId id="270" r:id="rId16"/>
     <p:sldId id="271" r:id="rId17"/>
+    <p:sldId id="272" r:id="rId18"/>
   </p:sldIdLst>
   <p:notesMasterIdLst>
-    <p:notesMasterId r:id="rId18"/>
+    <p:notesMasterId r:id="rId19"/>
   </p:notesMasterIdLst>
   <p:sldSz cx="12192000" cy="6858000"/>
   <p:notesSz cx="6858000" cy="12192000"/>
@@ -1157,6 +1158,94 @@
             <a:fld id="{F7021451-1387-4CA6-816F-3879F97B5CBC}" type="slidenum">
               <a:rPr lang="en-US"/>
               <a:t>16</a:t>
+            </a:fld>
+            <a:endParaRPr lang="en-US"/>
+          </a:p>
+        </p:txBody>
+      </p:sp>
+    </p:spTree>
+    <p:extLst>
+      <p:ext uri="{BB962C8B-B14F-4D97-AF65-F5344CB8AC3E}">
+        <p14:creationId xmlns:p14="http://schemas.microsoft.com/office/powerpoint/2010/main" val="1024086991"/>
+      </p:ext>
+    </p:extLst>
+  </p:cSld>
+  <p:clrMapOvr>
+    <a:masterClrMapping/>
+  </p:clrMapOvr>
+</p:notes>
+</file>
+
+<file path=ppt/notesSlides/notesSlide17.xml><?xml version="1.0" encoding="utf-8"?>
+<p:notes xmlns:a="http://schemas.openxmlformats.org/drawingml/2006/main" xmlns:r="http://schemas.openxmlformats.org/officeDocument/2006/relationships" xmlns:p="http://schemas.openxmlformats.org/presentationml/2006/main">
+  <p:cSld>
+    <p:spTree>
+      <p:nvGrpSpPr>
+        <p:cNvPr id="1" name=""/>
+        <p:cNvGrpSpPr/>
+        <p:nvPr/>
+      </p:nvGrpSpPr>
+      <p:grpSpPr>
+        <a:xfrm>
+          <a:off x="0" y="0"/>
+          <a:ext cx="0" cy="0"/>
+          <a:chOff x="0" y="0"/>
+          <a:chExt cx="0" cy="0"/>
+        </a:xfrm>
+      </p:grpSpPr>
+      <p:sp>
+        <p:nvSpPr>
+          <p:cNvPr id="2" name="Slide Image Placeholder 1"/>
+          <p:cNvSpPr>
+            <a:spLocks noGrp="1" noRot="1" noChangeAspect="1"/>
+          </p:cNvSpPr>
+          <p:nvPr>
+            <p:ph type="sldImg"/>
+          </p:nvPr>
+        </p:nvSpPr>
+        <p:spPr/>
+      </p:sp>
+      <p:sp>
+        <p:nvSpPr>
+          <p:cNvPr id="3" name="Notes Placeholder 2"/>
+          <p:cNvSpPr>
+            <a:spLocks noGrp="1"/>
+          </p:cNvSpPr>
+          <p:nvPr>
+            <p:ph type="body" idx="1"/>
+          </p:nvPr>
+        </p:nvSpPr>
+        <p:spPr/>
+        <p:txBody>
+          <a:bodyPr/>
+          <a:lstStyle/>
+          <a:p>
+            <a:r>
+              <a:rPr lang="en-US" dirty="0"/>
+              <a:t/>
+            </a:r>
+            <a:endParaRPr lang="en-US" dirty="0"/>
+          </a:p>
+        </p:txBody>
+      </p:sp>
+      <p:sp>
+        <p:nvSpPr>
+          <p:cNvPr id="4" name="Slide Number Placeholder 3"/>
+          <p:cNvSpPr>
+            <a:spLocks noGrp="1"/>
+          </p:cNvSpPr>
+          <p:nvPr>
+            <p:ph type="sldNum" sz="quarter" idx="10"/>
+          </p:nvPr>
+        </p:nvSpPr>
+        <p:spPr/>
+        <p:txBody>
+          <a:bodyPr/>
+          <a:lstStyle/>
+          <a:p>
+            <a:fld id="{F7021451-1387-4CA6-816F-3879F97B5CBC}" type="slidenum">
+              <a:rPr lang="en-US"/>
+              <a:t>17</a:t>
             </a:fld>
             <a:endParaRPr lang="en-US"/>
           </a:p>
@@ -8586,7 +8675,7 @@
                 <a:ea typeface="Calibri" pitchFamily="34" charset="-122"/>
                 <a:cs typeface="Calibri" pitchFamily="34" charset="-120"/>
               </a:rPr>
-              <a:t>Not done for you (needs your own accounts/credentials): Play Store upload, production TLS domain, SMTP/FCM credentials for real email/push.</a:t>
+              <a:t>Not done for you (needs your own accounts/credentials): Play Store upload, SMTP/FCM credentials for real email/push.</a:t>
             </a:r>
             <a:endParaRPr lang="en-US" sz="1150" dirty="0"/>
           </a:p>
@@ -8735,7 +8824,7 @@
                 <a:ea typeface="Cambria" pitchFamily="34" charset="-122"/>
                 <a:cs typeface="Cambria" pitchFamily="34" charset="-120"/>
               </a:rPr>
-              <a:t>Roadmap &amp; Conclusion</a:t>
+              <a:t>Live Deployment</a:t>
             </a:r>
             <a:endParaRPr lang="en-US" sz="3000" dirty="0"/>
           </a:p>
@@ -8749,8 +8838,8 @@
         </p:nvSpPr>
         <p:spPr>
           <a:xfrm>
-            <a:off x="548640" y="1554480"/>
-            <a:ext cx="5303520" cy="320040"/>
+            <a:off x="548640" y="960120"/>
+            <a:ext cx="11094415" cy="365760"/>
           </a:xfrm>
           <a:prstGeom prst="rect">
             <a:avLst/>
@@ -8766,23 +8855,50 @@
               <a:buNone/>
             </a:pPr>
             <a:r>
-              <a:rPr lang="en-US" sz="1500" b="1" dirty="0">
-                <a:solidFill>
-                  <a:srgbClr val="1A7A4C"/>
-                </a:solidFill>
-                <a:latin typeface="Cambria" pitchFamily="34" charset="0"/>
-                <a:ea typeface="Cambria" pitchFamily="34" charset="-122"/>
-                <a:cs typeface="Cambria" pitchFamily="34" charset="-120"/>
-              </a:rPr>
-              <a:t>What's next</a:t>
-            </a:r>
-            <a:endParaRPr lang="en-US" sz="1500" dirty="0"/>
-          </a:p>
-        </p:txBody>
+              <a:rPr lang="en-US" sz="1400" dirty="0">
+                <a:solidFill>
+                  <a:srgbClr val="5B6B60"/>
+                </a:solidFill>
+                <a:latin typeface="Calibri" pitchFamily="34" charset="0"/>
+                <a:ea typeface="Calibri" pitchFamily="34" charset="-122"/>
+                <a:cs typeface="Calibri" pitchFamily="34" charset="-120"/>
+              </a:rPr>
+              <a:t>Not just running locally -- deployed to the public internet and verified end-to-end</a:t>
+            </a:r>
+            <a:endParaRPr lang="en-US" sz="1400" dirty="0"/>
+          </a:p>
+        </p:txBody>
+      </p:sp>
+      <p:sp>
+        <p:nvSpPr>
+          <p:cNvPr id="4" name="Shape 2"/>
+          <p:cNvSpPr/>
+          <p:nvPr/>
+        </p:nvSpPr>
+        <p:spPr>
+          <a:xfrm>
+            <a:off x="609448" y="1600200"/>
+            <a:ext cx="5349240" cy="1371600"/>
+          </a:xfrm>
+          <a:prstGeom prst="roundRect">
+            <a:avLst>
+              <a:gd name="adj" fmla="val 6667"/>
+            </a:avLst>
+          </a:prstGeom>
+          <a:solidFill>
+            <a:srgbClr val="F6F8F6"/>
+          </a:solidFill>
+          <a:ln w="12700">
+            <a:solidFill>
+              <a:srgbClr val="E0E6E1"/>
+            </a:solidFill>
+            <a:prstDash val="solid"/>
+          </a:ln>
+        </p:spPr>
       </p:sp>
       <p:pic>
         <p:nvPicPr>
-          <p:cNvPr id="4" name="Image 0" descr="preencoded.png">    </p:cNvPr>
+          <p:cNvPr id="5" name="Image 0" descr="preencoded.png">    </p:cNvPr>
           <p:cNvPicPr>
             <a:picLocks noChangeAspect="1"/>
           </p:cNvPicPr>
@@ -8796,8 +8912,8 @@
         </p:blipFill>
         <p:spPr>
           <a:xfrm>
-            <a:off x="594360" y="1965960"/>
-            <a:ext cx="365760" cy="365760"/>
+            <a:off x="838048" y="2002536"/>
+            <a:ext cx="566928" cy="566928"/>
           </a:xfrm>
           <a:prstGeom prst="rect">
             <a:avLst/>
@@ -8806,14 +8922,14 @@
       </p:pic>
       <p:sp>
         <p:nvSpPr>
-          <p:cNvPr id="5" name="Text 2"/>
-          <p:cNvSpPr txBox="1"/>
-          <p:nvPr/>
-        </p:nvSpPr>
-        <p:spPr>
-          <a:xfrm>
-            <a:off x="1097280" y="1938528"/>
-            <a:ext cx="4846320" cy="594360"/>
+          <p:cNvPr id="6" name="Text 3"/>
+          <p:cNvSpPr txBox="1"/>
+          <p:nvPr/>
+        </p:nvSpPr>
+        <p:spPr>
+          <a:xfrm>
+            <a:off x="1569568" y="1764792"/>
+            <a:ext cx="4160520" cy="320040"/>
           </a:xfrm>
           <a:prstGeom prst="rect">
             <a:avLst/>
@@ -8829,7 +8945,85 @@
               <a:buNone/>
             </a:pPr>
             <a:r>
+              <a:rPr lang="en-US" sz="1450" b="1" dirty="0">
+                <a:solidFill>
+                  <a:srgbClr val="1C231F"/>
+                </a:solidFill>
+                <a:latin typeface="Cambria" pitchFamily="34" charset="0"/>
+                <a:ea typeface="Cambria" pitchFamily="34" charset="-122"/>
+                <a:cs typeface="Cambria" pitchFamily="34" charset="-120"/>
+              </a:rPr>
+              <a:t>Website</a:t>
+            </a:r>
+            <a:endParaRPr lang="en-US" sz="1450" dirty="0"/>
+          </a:p>
+        </p:txBody>
+      </p:sp>
+      <p:sp>
+        <p:nvSpPr>
+          <p:cNvPr id="7" name="Text 4"/>
+          <p:cNvSpPr txBox="1"/>
+          <p:nvPr/>
+        </p:nvSpPr>
+        <p:spPr>
+          <a:xfrm>
+            <a:off x="1569568" y="2103120"/>
+            <a:ext cx="4160520" cy="320040"/>
+          </a:xfrm>
+          <a:prstGeom prst="rect">
+            <a:avLst/>
+          </a:prstGeom>
+          <a:noFill/>
+          <a:ln/>
+        </p:spPr>
+        <p:txBody>
+          <a:bodyPr wrap="square" lIns="0" tIns="0" rIns="0" bIns="0" rtlCol="0" anchor="ctr"/>
+          <a:lstStyle/>
+          <a:p>
+            <a:pPr indent="0" marL="0">
+              <a:buNone/>
+            </a:pPr>
+            <a:r>
               <a:rPr lang="en-US" sz="1150" dirty="0">
+                <a:solidFill>
+                  <a:srgbClr val="1A7A4C"/>
+                </a:solidFill>
+                <a:latin typeface="Courier New" pitchFamily="34" charset="0"/>
+                <a:ea typeface="Courier New" pitchFamily="34" charset="-122"/>
+                <a:cs typeface="Courier New" pitchFamily="34" charset="-120"/>
+              </a:rPr>
+              <a:t>nellai-green-civic.netlify.app</a:t>
+            </a:r>
+            <a:endParaRPr lang="en-US" sz="1150" dirty="0"/>
+          </a:p>
+        </p:txBody>
+      </p:sp>
+      <p:sp>
+        <p:nvSpPr>
+          <p:cNvPr id="8" name="Text 5"/>
+          <p:cNvSpPr txBox="1"/>
+          <p:nvPr/>
+        </p:nvSpPr>
+        <p:spPr>
+          <a:xfrm>
+            <a:off x="1569568" y="2441448"/>
+            <a:ext cx="4160520" cy="274320"/>
+          </a:xfrm>
+          <a:prstGeom prst="rect">
+            <a:avLst/>
+          </a:prstGeom>
+          <a:noFill/>
+          <a:ln/>
+        </p:spPr>
+        <p:txBody>
+          <a:bodyPr wrap="square" lIns="0" tIns="0" rIns="0" bIns="0" rtlCol="0" anchor="ctr"/>
+          <a:lstStyle/>
+          <a:p>
+            <a:pPr indent="0" marL="0">
+              <a:buNone/>
+            </a:pPr>
+            <a:r>
+              <a:rPr lang="en-US" sz="1000" dirty="0">
                 <a:solidFill>
                   <a:srgbClr val="5B6B60"/>
                 </a:solidFill>
@@ -8837,15 +9031,42 @@
                 <a:ea typeface="Calibri" pitchFamily="34" charset="-122"/>
                 <a:cs typeface="Calibri" pitchFamily="34" charset="-120"/>
               </a:rPr>
-              <a:t>Play Store production release (signing key, store listing, Data Safety form)</a:t>
-            </a:r>
-            <a:endParaRPr lang="en-US" sz="1150" dirty="0"/>
-          </a:p>
-        </p:txBody>
+              <a:t>Netlify</a:t>
+            </a:r>
+            <a:endParaRPr lang="en-US" sz="1000" dirty="0"/>
+          </a:p>
+        </p:txBody>
+      </p:sp>
+      <p:sp>
+        <p:nvSpPr>
+          <p:cNvPr id="9" name="Shape 6"/>
+          <p:cNvSpPr/>
+          <p:nvPr/>
+        </p:nvSpPr>
+        <p:spPr>
+          <a:xfrm>
+            <a:off x="6233008" y="1600200"/>
+            <a:ext cx="5349240" cy="1371600"/>
+          </a:xfrm>
+          <a:prstGeom prst="roundRect">
+            <a:avLst>
+              <a:gd name="adj" fmla="val 6667"/>
+            </a:avLst>
+          </a:prstGeom>
+          <a:solidFill>
+            <a:srgbClr val="F6F8F6"/>
+          </a:solidFill>
+          <a:ln w="12700">
+            <a:solidFill>
+              <a:srgbClr val="E0E6E1"/>
+            </a:solidFill>
+            <a:prstDash val="solid"/>
+          </a:ln>
+        </p:spPr>
       </p:sp>
       <p:pic>
         <p:nvPicPr>
-          <p:cNvPr id="6" name="Image 1" descr="preencoded.png">    </p:cNvPr>
+          <p:cNvPr id="10" name="Image 1" descr="preencoded.png">    </p:cNvPr>
           <p:cNvPicPr>
             <a:picLocks noChangeAspect="1"/>
           </p:cNvPicPr>
@@ -8859,8 +9080,8 @@
         </p:blipFill>
         <p:spPr>
           <a:xfrm>
-            <a:off x="594360" y="2743200"/>
-            <a:ext cx="365760" cy="365760"/>
+            <a:off x="6461608" y="2002536"/>
+            <a:ext cx="566928" cy="566928"/>
           </a:xfrm>
           <a:prstGeom prst="rect">
             <a:avLst/>
@@ -8869,14 +9090,14 @@
       </p:pic>
       <p:sp>
         <p:nvSpPr>
-          <p:cNvPr id="7" name="Text 3"/>
-          <p:cNvSpPr txBox="1"/>
-          <p:nvPr/>
-        </p:nvSpPr>
-        <p:spPr>
-          <a:xfrm>
-            <a:off x="1097280" y="2715768"/>
-            <a:ext cx="4846320" cy="594360"/>
+          <p:cNvPr id="11" name="Text 7"/>
+          <p:cNvSpPr txBox="1"/>
+          <p:nvPr/>
+        </p:nvSpPr>
+        <p:spPr>
+          <a:xfrm>
+            <a:off x="7193128" y="1764792"/>
+            <a:ext cx="4160520" cy="320040"/>
           </a:xfrm>
           <a:prstGeom prst="rect">
             <a:avLst/>
@@ -8892,7 +9113,85 @@
               <a:buNone/>
             </a:pPr>
             <a:r>
+              <a:rPr lang="en-US" sz="1450" b="1" dirty="0">
+                <a:solidFill>
+                  <a:srgbClr val="1C231F"/>
+                </a:solidFill>
+                <a:latin typeface="Cambria" pitchFamily="34" charset="0"/>
+                <a:ea typeface="Cambria" pitchFamily="34" charset="-122"/>
+                <a:cs typeface="Cambria" pitchFamily="34" charset="-120"/>
+              </a:rPr>
+              <a:t>Backend API</a:t>
+            </a:r>
+            <a:endParaRPr lang="en-US" sz="1450" dirty="0"/>
+          </a:p>
+        </p:txBody>
+      </p:sp>
+      <p:sp>
+        <p:nvSpPr>
+          <p:cNvPr id="12" name="Text 8"/>
+          <p:cNvSpPr txBox="1"/>
+          <p:nvPr/>
+        </p:nvSpPr>
+        <p:spPr>
+          <a:xfrm>
+            <a:off x="7193128" y="2103120"/>
+            <a:ext cx="4160520" cy="320040"/>
+          </a:xfrm>
+          <a:prstGeom prst="rect">
+            <a:avLst/>
+          </a:prstGeom>
+          <a:noFill/>
+          <a:ln/>
+        </p:spPr>
+        <p:txBody>
+          <a:bodyPr wrap="square" lIns="0" tIns="0" rIns="0" bIns="0" rtlCol="0" anchor="ctr"/>
+          <a:lstStyle/>
+          <a:p>
+            <a:pPr indent="0" marL="0">
+              <a:buNone/>
+            </a:pPr>
+            <a:r>
               <a:rPr lang="en-US" sz="1150" dirty="0">
+                <a:solidFill>
+                  <a:srgbClr val="1A7A4C"/>
+                </a:solidFill>
+                <a:latin typeface="Courier New" pitchFamily="34" charset="0"/>
+                <a:ea typeface="Courier New" pitchFamily="34" charset="-122"/>
+                <a:cs typeface="Courier New" pitchFamily="34" charset="-120"/>
+              </a:rPr>
+              <a:t>nellai-backend.onrender.com</a:t>
+            </a:r>
+            <a:endParaRPr lang="en-US" sz="1150" dirty="0"/>
+          </a:p>
+        </p:txBody>
+      </p:sp>
+      <p:sp>
+        <p:nvSpPr>
+          <p:cNvPr id="13" name="Text 9"/>
+          <p:cNvSpPr txBox="1"/>
+          <p:nvPr/>
+        </p:nvSpPr>
+        <p:spPr>
+          <a:xfrm>
+            <a:off x="7193128" y="2441448"/>
+            <a:ext cx="4160520" cy="274320"/>
+          </a:xfrm>
+          <a:prstGeom prst="rect">
+            <a:avLst/>
+          </a:prstGeom>
+          <a:noFill/>
+          <a:ln/>
+        </p:spPr>
+        <p:txBody>
+          <a:bodyPr wrap="square" lIns="0" tIns="0" rIns="0" bIns="0" rtlCol="0" anchor="ctr"/>
+          <a:lstStyle/>
+          <a:p>
+            <a:pPr indent="0" marL="0">
+              <a:buNone/>
+            </a:pPr>
+            <a:r>
+              <a:rPr lang="en-US" sz="1000" dirty="0">
                 <a:solidFill>
                   <a:srgbClr val="5B6B60"/>
                 </a:solidFill>
@@ -8900,15 +9199,42 @@
                 <a:ea typeface="Calibri" pitchFamily="34" charset="-122"/>
                 <a:cs typeface="Calibri" pitchFamily="34" charset="-120"/>
               </a:rPr>
-              <a:t>Community-contributed modules: flood monitoring, temple water tanks, school environmental clubs</a:t>
-            </a:r>
-            <a:endParaRPr lang="en-US" sz="1150" dirty="0"/>
-          </a:p>
-        </p:txBody>
+              <a:t>Render</a:t>
+            </a:r>
+            <a:endParaRPr lang="en-US" sz="1000" dirty="0"/>
+          </a:p>
+        </p:txBody>
+      </p:sp>
+      <p:sp>
+        <p:nvSpPr>
+          <p:cNvPr id="14" name="Shape 10"/>
+          <p:cNvSpPr/>
+          <p:nvPr/>
+        </p:nvSpPr>
+        <p:spPr>
+          <a:xfrm>
+            <a:off x="609448" y="3227832"/>
+            <a:ext cx="5349240" cy="1371600"/>
+          </a:xfrm>
+          <a:prstGeom prst="roundRect">
+            <a:avLst>
+              <a:gd name="adj" fmla="val 6667"/>
+            </a:avLst>
+          </a:prstGeom>
+          <a:solidFill>
+            <a:srgbClr val="F6F8F6"/>
+          </a:solidFill>
+          <a:ln w="12700">
+            <a:solidFill>
+              <a:srgbClr val="E0E6E1"/>
+            </a:solidFill>
+            <a:prstDash val="solid"/>
+          </a:ln>
+        </p:spPr>
       </p:sp>
       <p:pic>
         <p:nvPicPr>
-          <p:cNvPr id="8" name="Image 2" descr="preencoded.png">    </p:cNvPr>
+          <p:cNvPr id="15" name="Image 2" descr="preencoded.png">    </p:cNvPr>
           <p:cNvPicPr>
             <a:picLocks noChangeAspect="1"/>
           </p:cNvPicPr>
@@ -8922,8 +9248,8 @@
         </p:blipFill>
         <p:spPr>
           <a:xfrm>
-            <a:off x="594360" y="3520440"/>
-            <a:ext cx="365760" cy="365760"/>
+            <a:off x="838048" y="3630168"/>
+            <a:ext cx="566928" cy="566928"/>
           </a:xfrm>
           <a:prstGeom prst="rect">
             <a:avLst/>
@@ -8932,14 +9258,14 @@
       </p:pic>
       <p:sp>
         <p:nvSpPr>
-          <p:cNvPr id="9" name="Text 4"/>
-          <p:cNvSpPr txBox="1"/>
-          <p:nvPr/>
-        </p:nvSpPr>
-        <p:spPr>
-          <a:xfrm>
-            <a:off x="1097280" y="3493008"/>
-            <a:ext cx="4846320" cy="594360"/>
+          <p:cNvPr id="16" name="Text 11"/>
+          <p:cNvSpPr txBox="1"/>
+          <p:nvPr/>
+        </p:nvSpPr>
+        <p:spPr>
+          <a:xfrm>
+            <a:off x="1569568" y="3392424"/>
+            <a:ext cx="4160520" cy="320040"/>
           </a:xfrm>
           <a:prstGeom prst="rect">
             <a:avLst/>
@@ -8955,7 +9281,85 @@
               <a:buNone/>
             </a:pPr>
             <a:r>
+              <a:rPr lang="en-US" sz="1450" b="1" dirty="0">
+                <a:solidFill>
+                  <a:srgbClr val="1C231F"/>
+                </a:solidFill>
+                <a:latin typeface="Cambria" pitchFamily="34" charset="0"/>
+                <a:ea typeface="Cambria" pitchFamily="34" charset="-122"/>
+                <a:cs typeface="Cambria" pitchFamily="34" charset="-120"/>
+              </a:rPr>
+              <a:t>AI Service</a:t>
+            </a:r>
+            <a:endParaRPr lang="en-US" sz="1450" dirty="0"/>
+          </a:p>
+        </p:txBody>
+      </p:sp>
+      <p:sp>
+        <p:nvSpPr>
+          <p:cNvPr id="17" name="Text 12"/>
+          <p:cNvSpPr txBox="1"/>
+          <p:nvPr/>
+        </p:nvSpPr>
+        <p:spPr>
+          <a:xfrm>
+            <a:off x="1569568" y="3730752"/>
+            <a:ext cx="4160520" cy="320040"/>
+          </a:xfrm>
+          <a:prstGeom prst="rect">
+            <a:avLst/>
+          </a:prstGeom>
+          <a:noFill/>
+          <a:ln/>
+        </p:spPr>
+        <p:txBody>
+          <a:bodyPr wrap="square" lIns="0" tIns="0" rIns="0" bIns="0" rtlCol="0" anchor="ctr"/>
+          <a:lstStyle/>
+          <a:p>
+            <a:pPr indent="0" marL="0">
+              <a:buNone/>
+            </a:pPr>
+            <a:r>
               <a:rPr lang="en-US" sz="1150" dirty="0">
+                <a:solidFill>
+                  <a:srgbClr val="1A7A4C"/>
+                </a:solidFill>
+                <a:latin typeface="Courier New" pitchFamily="34" charset="0"/>
+                <a:ea typeface="Courier New" pitchFamily="34" charset="-122"/>
+                <a:cs typeface="Courier New" pitchFamily="34" charset="-120"/>
+              </a:rPr>
+              <a:t>nellai-ai.onrender.com</a:t>
+            </a:r>
+            <a:endParaRPr lang="en-US" sz="1150" dirty="0"/>
+          </a:p>
+        </p:txBody>
+      </p:sp>
+      <p:sp>
+        <p:nvSpPr>
+          <p:cNvPr id="18" name="Text 13"/>
+          <p:cNvSpPr txBox="1"/>
+          <p:nvPr/>
+        </p:nvSpPr>
+        <p:spPr>
+          <a:xfrm>
+            <a:off x="1569568" y="4069080"/>
+            <a:ext cx="4160520" cy="274320"/>
+          </a:xfrm>
+          <a:prstGeom prst="rect">
+            <a:avLst/>
+          </a:prstGeom>
+          <a:noFill/>
+          <a:ln/>
+        </p:spPr>
+        <p:txBody>
+          <a:bodyPr wrap="square" lIns="0" tIns="0" rIns="0" bIns="0" rtlCol="0" anchor="ctr"/>
+          <a:lstStyle/>
+          <a:p>
+            <a:pPr indent="0" marL="0">
+              <a:buNone/>
+            </a:pPr>
+            <a:r>
+              <a:rPr lang="en-US" sz="1000" dirty="0">
                 <a:solidFill>
                   <a:srgbClr val="5B6B60"/>
                 </a:solidFill>
@@ -8963,15 +9367,42 @@
                 <a:ea typeface="Calibri" pitchFamily="34" charset="-122"/>
                 <a:cs typeface="Calibri" pitchFamily="34" charset="-120"/>
               </a:rPr>
-              <a:t>Fine-tuned, domain-specific vision model to replace the auxiliary ImageNet signal</a:t>
-            </a:r>
-            <a:endParaRPr lang="en-US" sz="1150" dirty="0"/>
-          </a:p>
-        </p:txBody>
+              <a:t>Render</a:t>
+            </a:r>
+            <a:endParaRPr lang="en-US" sz="1000" dirty="0"/>
+          </a:p>
+        </p:txBody>
+      </p:sp>
+      <p:sp>
+        <p:nvSpPr>
+          <p:cNvPr id="19" name="Shape 14"/>
+          <p:cNvSpPr/>
+          <p:nvPr/>
+        </p:nvSpPr>
+        <p:spPr>
+          <a:xfrm>
+            <a:off x="6233008" y="3227832"/>
+            <a:ext cx="5349240" cy="1371600"/>
+          </a:xfrm>
+          <a:prstGeom prst="roundRect">
+            <a:avLst>
+              <a:gd name="adj" fmla="val 6667"/>
+            </a:avLst>
+          </a:prstGeom>
+          <a:solidFill>
+            <a:srgbClr val="F6F8F6"/>
+          </a:solidFill>
+          <a:ln w="12700">
+            <a:solidFill>
+              <a:srgbClr val="E0E6E1"/>
+            </a:solidFill>
+            <a:prstDash val="solid"/>
+          </a:ln>
+        </p:spPr>
       </p:sp>
       <p:pic>
         <p:nvPicPr>
-          <p:cNvPr id="10" name="Image 3" descr="preencoded.png">    </p:cNvPr>
+          <p:cNvPr id="20" name="Image 3" descr="preencoded.png">    </p:cNvPr>
           <p:cNvPicPr>
             <a:picLocks noChangeAspect="1"/>
           </p:cNvPicPr>
@@ -8985,8 +9416,8 @@
         </p:blipFill>
         <p:spPr>
           <a:xfrm>
-            <a:off x="594360" y="4297680"/>
-            <a:ext cx="365760" cy="365760"/>
+            <a:off x="6461608" y="3630168"/>
+            <a:ext cx="566928" cy="566928"/>
           </a:xfrm>
           <a:prstGeom prst="rect">
             <a:avLst/>
@@ -8995,14 +9426,14 @@
       </p:pic>
       <p:sp>
         <p:nvSpPr>
-          <p:cNvPr id="11" name="Text 5"/>
-          <p:cNvSpPr txBox="1"/>
-          <p:nvPr/>
-        </p:nvSpPr>
-        <p:spPr>
-          <a:xfrm>
-            <a:off x="1097280" y="4270248"/>
-            <a:ext cx="4846320" cy="594360"/>
+          <p:cNvPr id="21" name="Text 15"/>
+          <p:cNvSpPr txBox="1"/>
+          <p:nvPr/>
+        </p:nvSpPr>
+        <p:spPr>
+          <a:xfrm>
+            <a:off x="7193128" y="3392424"/>
+            <a:ext cx="4160520" cy="320040"/>
           </a:xfrm>
           <a:prstGeom prst="rect">
             <a:avLst/>
@@ -9018,7 +9449,85 @@
               <a:buNone/>
             </a:pPr>
             <a:r>
+              <a:rPr lang="en-US" sz="1450" b="1" dirty="0">
+                <a:solidFill>
+                  <a:srgbClr val="1C231F"/>
+                </a:solidFill>
+                <a:latin typeface="Cambria" pitchFamily="34" charset="0"/>
+                <a:ea typeface="Cambria" pitchFamily="34" charset="-122"/>
+                <a:cs typeface="Cambria" pitchFamily="34" charset="-120"/>
+              </a:rPr>
+              <a:t>Source Code</a:t>
+            </a:r>
+            <a:endParaRPr lang="en-US" sz="1450" dirty="0"/>
+          </a:p>
+        </p:txBody>
+      </p:sp>
+      <p:sp>
+        <p:nvSpPr>
+          <p:cNvPr id="22" name="Text 16"/>
+          <p:cNvSpPr txBox="1"/>
+          <p:nvPr/>
+        </p:nvSpPr>
+        <p:spPr>
+          <a:xfrm>
+            <a:off x="7193128" y="3730752"/>
+            <a:ext cx="4160520" cy="320040"/>
+          </a:xfrm>
+          <a:prstGeom prst="rect">
+            <a:avLst/>
+          </a:prstGeom>
+          <a:noFill/>
+          <a:ln/>
+        </p:spPr>
+        <p:txBody>
+          <a:bodyPr wrap="square" lIns="0" tIns="0" rIns="0" bIns="0" rtlCol="0" anchor="ctr"/>
+          <a:lstStyle/>
+          <a:p>
+            <a:pPr indent="0" marL="0">
+              <a:buNone/>
+            </a:pPr>
+            <a:r>
               <a:rPr lang="en-US" sz="1150" dirty="0">
+                <a:solidFill>
+                  <a:srgbClr val="1A7A4C"/>
+                </a:solidFill>
+                <a:latin typeface="Courier New" pitchFamily="34" charset="0"/>
+                <a:ea typeface="Courier New" pitchFamily="34" charset="-122"/>
+                <a:cs typeface="Courier New" pitchFamily="34" charset="-120"/>
+              </a:rPr>
+              <a:t>github.com/Santhiya2001/nellai-green-civic</a:t>
+            </a:r>
+            <a:endParaRPr lang="en-US" sz="1150" dirty="0"/>
+          </a:p>
+        </p:txBody>
+      </p:sp>
+      <p:sp>
+        <p:nvSpPr>
+          <p:cNvPr id="23" name="Text 17"/>
+          <p:cNvSpPr txBox="1"/>
+          <p:nvPr/>
+        </p:nvSpPr>
+        <p:spPr>
+          <a:xfrm>
+            <a:off x="7193128" y="4069080"/>
+            <a:ext cx="4160520" cy="274320"/>
+          </a:xfrm>
+          <a:prstGeom prst="rect">
+            <a:avLst/>
+          </a:prstGeom>
+          <a:noFill/>
+          <a:ln/>
+        </p:spPr>
+        <p:txBody>
+          <a:bodyPr wrap="square" lIns="0" tIns="0" rIns="0" bIns="0" rtlCol="0" anchor="ctr"/>
+          <a:lstStyle/>
+          <a:p>
+            <a:pPr indent="0" marL="0">
+              <a:buNone/>
+            </a:pPr>
+            <a:r>
+              <a:rPr lang="en-US" sz="1000" dirty="0">
                 <a:solidFill>
                   <a:srgbClr val="5B6B60"/>
                 </a:solidFill>
@@ -9026,37 +9535,42 @@
                 <a:ea typeface="Calibri" pitchFamily="34" charset="-122"/>
                 <a:cs typeface="Calibri" pitchFamily="34" charset="-120"/>
               </a:rPr>
-              <a:t>Multi-district configuration -- Tirunelveli as the reference deployment, not the ceiling</a:t>
-            </a:r>
-            <a:endParaRPr lang="en-US" sz="1150" dirty="0"/>
-          </a:p>
-        </p:txBody>
-      </p:sp>
-      <p:sp>
-        <p:nvSpPr>
-          <p:cNvPr id="12" name="Shape 6"/>
+              <a:t>GitHub (public)</a:t>
+            </a:r>
+            <a:endParaRPr lang="en-US" sz="1000" dirty="0"/>
+          </a:p>
+        </p:txBody>
+      </p:sp>
+      <p:sp>
+        <p:nvSpPr>
+          <p:cNvPr id="24" name="Shape 18"/>
           <p:cNvSpPr/>
           <p:nvPr/>
         </p:nvSpPr>
         <p:spPr>
           <a:xfrm>
-            <a:off x="6309360" y="1554480"/>
-            <a:ext cx="5349240" cy="4297680"/>
+            <a:off x="609448" y="4946904"/>
+            <a:ext cx="10972800" cy="1051560"/>
           </a:xfrm>
           <a:prstGeom prst="roundRect">
             <a:avLst>
-              <a:gd name="adj" fmla="val 2553"/>
+              <a:gd name="adj" fmla="val 8696"/>
             </a:avLst>
           </a:prstGeom>
           <a:solidFill>
-            <a:srgbClr val="135C39"/>
+            <a:srgbClr val="E3EEE6"/>
           </a:solidFill>
-          <a:ln/>
+          <a:ln w="12700">
+            <a:solidFill>
+              <a:srgbClr val="97BC62"/>
+            </a:solidFill>
+            <a:prstDash val="solid"/>
+          </a:ln>
         </p:spPr>
       </p:sp>
       <p:pic>
         <p:nvPicPr>
-          <p:cNvPr id="13" name="Image 4" descr="preencoded.png">    </p:cNvPr>
+          <p:cNvPr id="25" name="Image 4" descr="preencoded.png">    </p:cNvPr>
           <p:cNvPicPr>
             <a:picLocks noChangeAspect="1"/>
           </p:cNvPicPr>
@@ -9070,6 +9584,531 @@
         </p:blipFill>
         <p:spPr>
           <a:xfrm>
+            <a:off x="838048" y="5175504"/>
+            <a:ext cx="548640" cy="548640"/>
+          </a:xfrm>
+          <a:prstGeom prst="rect">
+            <a:avLst/>
+          </a:prstGeom>
+        </p:spPr>
+      </p:pic>
+      <p:sp>
+        <p:nvSpPr>
+          <p:cNvPr id="26" name="Text 19"/>
+          <p:cNvSpPr txBox="1"/>
+          <p:nvPr/>
+        </p:nvSpPr>
+        <p:spPr>
+          <a:xfrm>
+            <a:off x="1569568" y="5056632"/>
+            <a:ext cx="9784080" cy="822960"/>
+          </a:xfrm>
+          <a:prstGeom prst="rect">
+            <a:avLst/>
+          </a:prstGeom>
+          <a:noFill/>
+          <a:ln/>
+        </p:spPr>
+        <p:txBody>
+          <a:bodyPr wrap="square" lIns="0" tIns="0" rIns="0" bIns="0" rtlCol="0" anchor="ctr"/>
+          <a:lstStyle/>
+          <a:p>
+            <a:pPr indent="0" marL="0">
+              <a:buNone/>
+            </a:pPr>
+            <a:r>
+              <a:rPr lang="en-US" sz="1100" dirty="0">
+                <a:solidFill>
+                  <a:srgbClr val="135C39"/>
+                </a:solidFill>
+                <a:latin typeface="Calibri" pitchFamily="34" charset="0"/>
+                <a:ea typeface="Calibri" pitchFamily="34" charset="-122"/>
+                <a:cs typeface="Calibri" pitchFamily="34" charset="-120"/>
+              </a:rPr>
+              <a:t>Verified live, not just “deployed”: registered a citizen, logged in, and filed a complaint against the production backend -- GPS, PostGIS, and cross-service AI classification (Render → Render) all confirmed working through real Netlify → Render traffic with CORS correctly configured.</a:t>
+            </a:r>
+            <a:endParaRPr lang="en-US" sz="1100" dirty="0"/>
+          </a:p>
+        </p:txBody>
+      </p:sp>
+      <p:sp>
+        <p:nvSpPr>
+          <p:cNvPr id="27" name="Text 20"/>
+          <p:cNvSpPr txBox="1"/>
+          <p:nvPr/>
+        </p:nvSpPr>
+        <p:spPr>
+          <a:xfrm>
+            <a:off x="457200" y="6473952"/>
+            <a:ext cx="7315200" cy="274320"/>
+          </a:xfrm>
+          <a:prstGeom prst="rect">
+            <a:avLst/>
+          </a:prstGeom>
+          <a:noFill/>
+          <a:ln/>
+        </p:spPr>
+        <p:txBody>
+          <a:bodyPr wrap="square" lIns="0" tIns="0" rIns="0" bIns="0" rtlCol="0" anchor="ctr"/>
+          <a:lstStyle/>
+          <a:p>
+            <a:pPr algn="l" indent="0" marL="0">
+              <a:buNone/>
+            </a:pPr>
+            <a:r>
+              <a:rPr lang="en-US" sz="1000" dirty="0">
+                <a:solidFill>
+                  <a:srgbClr val="5B6B60"/>
+                </a:solidFill>
+                <a:latin typeface="Calibri" pitchFamily="34" charset="0"/>
+                <a:ea typeface="Calibri" pitchFamily="34" charset="-122"/>
+                <a:cs typeface="Calibri" pitchFamily="34" charset="-120"/>
+              </a:rPr>
+              <a:t>Nellai Green &amp; Civic</a:t>
+            </a:r>
+            <a:endParaRPr lang="en-US" sz="1000" dirty="0"/>
+          </a:p>
+        </p:txBody>
+      </p:sp>
+      <p:sp>
+        <p:nvSpPr>
+          <p:cNvPr id="28" name="Text 21"/>
+          <p:cNvSpPr txBox="1"/>
+          <p:nvPr/>
+        </p:nvSpPr>
+        <p:spPr>
+          <a:xfrm>
+            <a:off x="11277295" y="6473952"/>
+            <a:ext cx="457200" cy="274320"/>
+          </a:xfrm>
+          <a:prstGeom prst="rect">
+            <a:avLst/>
+          </a:prstGeom>
+          <a:noFill/>
+          <a:ln/>
+        </p:spPr>
+        <p:txBody>
+          <a:bodyPr wrap="square" lIns="0" tIns="0" rIns="0" bIns="0" rtlCol="0" anchor="ctr"/>
+          <a:lstStyle/>
+          <a:p>
+            <a:pPr algn="r" indent="0" marL="0">
+              <a:buNone/>
+            </a:pPr>
+            <a:r>
+              <a:rPr lang="en-US" sz="1000" dirty="0">
+                <a:solidFill>
+                  <a:srgbClr val="5B6B60"/>
+                </a:solidFill>
+                <a:latin typeface="Calibri" pitchFamily="34" charset="0"/>
+                <a:ea typeface="Calibri" pitchFamily="34" charset="-122"/>
+                <a:cs typeface="Calibri" pitchFamily="34" charset="-120"/>
+              </a:rPr>
+              <a:t>16</a:t>
+            </a:r>
+            <a:endParaRPr lang="en-US" sz="1000" dirty="0"/>
+          </a:p>
+        </p:txBody>
+      </p:sp>
+    </p:spTree>
+  </p:cSld>
+  <p:clrMapOvr>
+    <a:masterClrMapping/>
+  </p:clrMapOvr>
+</p:sld>
+</file>
+
+<file path=ppt/slides/slide17.xml><?xml version="1.0" encoding="utf-8"?>
+<p:sld xmlns:a="http://schemas.openxmlformats.org/drawingml/2006/main" xmlns:r="http://schemas.openxmlformats.org/officeDocument/2006/relationships" xmlns:p="http://schemas.openxmlformats.org/presentationml/2006/main">
+  <p:cSld name="Slide 17">
+    <p:bg>
+      <p:bgPr>
+        <a:solidFill>
+          <a:srgbClr val="FFFFFF"/>
+        </a:solidFill>
+      </p:bgPr>
+    </p:bg>
+    <p:spTree>
+      <p:nvGrpSpPr>
+        <p:cNvPr id="1" name=""/>
+        <p:cNvGrpSpPr/>
+        <p:nvPr/>
+      </p:nvGrpSpPr>
+      <p:grpSpPr>
+        <a:xfrm>
+          <a:off x="0" y="0"/>
+          <a:ext cx="0" cy="0"/>
+          <a:chOff x="0" y="0"/>
+          <a:chExt cx="0" cy="0"/>
+        </a:xfrm>
+      </p:grpSpPr>
+      <p:sp>
+        <p:nvSpPr>
+          <p:cNvPr id="2" name="Text 0"/>
+          <p:cNvSpPr txBox="1"/>
+          <p:nvPr/>
+        </p:nvSpPr>
+        <p:spPr>
+          <a:xfrm>
+            <a:off x="548640" y="365760"/>
+            <a:ext cx="11094415" cy="640080"/>
+          </a:xfrm>
+          <a:prstGeom prst="rect">
+            <a:avLst/>
+          </a:prstGeom>
+          <a:noFill/>
+          <a:ln/>
+        </p:spPr>
+        <p:txBody>
+          <a:bodyPr wrap="square" lIns="0" tIns="0" rIns="0" bIns="0" rtlCol="0" anchor="ctr"/>
+          <a:lstStyle/>
+          <a:p>
+            <a:pPr indent="0" marL="0">
+              <a:buNone/>
+            </a:pPr>
+            <a:r>
+              <a:rPr lang="en-US" sz="3000" b="1" dirty="0">
+                <a:solidFill>
+                  <a:srgbClr val="1C231F"/>
+                </a:solidFill>
+                <a:latin typeface="Cambria" pitchFamily="34" charset="0"/>
+                <a:ea typeface="Cambria" pitchFamily="34" charset="-122"/>
+                <a:cs typeface="Cambria" pitchFamily="34" charset="-120"/>
+              </a:rPr>
+              <a:t>Roadmap &amp; Conclusion</a:t>
+            </a:r>
+            <a:endParaRPr lang="en-US" sz="3000" dirty="0"/>
+          </a:p>
+        </p:txBody>
+      </p:sp>
+      <p:sp>
+        <p:nvSpPr>
+          <p:cNvPr id="3" name="Text 1"/>
+          <p:cNvSpPr txBox="1"/>
+          <p:nvPr/>
+        </p:nvSpPr>
+        <p:spPr>
+          <a:xfrm>
+            <a:off x="548640" y="1554480"/>
+            <a:ext cx="5303520" cy="320040"/>
+          </a:xfrm>
+          <a:prstGeom prst="rect">
+            <a:avLst/>
+          </a:prstGeom>
+          <a:noFill/>
+          <a:ln/>
+        </p:spPr>
+        <p:txBody>
+          <a:bodyPr wrap="square" lIns="0" tIns="0" rIns="0" bIns="0" rtlCol="0" anchor="ctr"/>
+          <a:lstStyle/>
+          <a:p>
+            <a:pPr indent="0" marL="0">
+              <a:buNone/>
+            </a:pPr>
+            <a:r>
+              <a:rPr lang="en-US" sz="1500" b="1" dirty="0">
+                <a:solidFill>
+                  <a:srgbClr val="1A7A4C"/>
+                </a:solidFill>
+                <a:latin typeface="Cambria" pitchFamily="34" charset="0"/>
+                <a:ea typeface="Cambria" pitchFamily="34" charset="-122"/>
+                <a:cs typeface="Cambria" pitchFamily="34" charset="-120"/>
+              </a:rPr>
+              <a:t>What's next</a:t>
+            </a:r>
+            <a:endParaRPr lang="en-US" sz="1500" dirty="0"/>
+          </a:p>
+        </p:txBody>
+      </p:sp>
+      <p:pic>
+        <p:nvPicPr>
+          <p:cNvPr id="4" name="Image 0" descr="preencoded.png">    </p:cNvPr>
+          <p:cNvPicPr>
+            <a:picLocks noChangeAspect="1"/>
+          </p:cNvPicPr>
+          <p:nvPr/>
+        </p:nvPicPr>
+        <p:blipFill>
+          <a:blip r:embed="rId1"/>
+          <a:stretch>
+            <a:fillRect/>
+          </a:stretch>
+        </p:blipFill>
+        <p:spPr>
+          <a:xfrm>
+            <a:off x="594360" y="1965960"/>
+            <a:ext cx="365760" cy="365760"/>
+          </a:xfrm>
+          <a:prstGeom prst="rect">
+            <a:avLst/>
+          </a:prstGeom>
+        </p:spPr>
+      </p:pic>
+      <p:sp>
+        <p:nvSpPr>
+          <p:cNvPr id="5" name="Text 2"/>
+          <p:cNvSpPr txBox="1"/>
+          <p:nvPr/>
+        </p:nvSpPr>
+        <p:spPr>
+          <a:xfrm>
+            <a:off x="1097280" y="1938528"/>
+            <a:ext cx="4846320" cy="594360"/>
+          </a:xfrm>
+          <a:prstGeom prst="rect">
+            <a:avLst/>
+          </a:prstGeom>
+          <a:noFill/>
+          <a:ln/>
+        </p:spPr>
+        <p:txBody>
+          <a:bodyPr wrap="square" lIns="0" tIns="0" rIns="0" bIns="0" rtlCol="0" anchor="ctr"/>
+          <a:lstStyle/>
+          <a:p>
+            <a:pPr indent="0" marL="0">
+              <a:buNone/>
+            </a:pPr>
+            <a:r>
+              <a:rPr lang="en-US" sz="1150" dirty="0">
+                <a:solidFill>
+                  <a:srgbClr val="5B6B60"/>
+                </a:solidFill>
+                <a:latin typeface="Calibri" pitchFamily="34" charset="0"/>
+                <a:ea typeface="Calibri" pitchFamily="34" charset="-122"/>
+                <a:cs typeface="Calibri" pitchFamily="34" charset="-120"/>
+              </a:rPr>
+              <a:t>Play Store production release (signing key, store listing, Data Safety form)</a:t>
+            </a:r>
+            <a:endParaRPr lang="en-US" sz="1150" dirty="0"/>
+          </a:p>
+        </p:txBody>
+      </p:sp>
+      <p:pic>
+        <p:nvPicPr>
+          <p:cNvPr id="6" name="Image 1" descr="preencoded.png">    </p:cNvPr>
+          <p:cNvPicPr>
+            <a:picLocks noChangeAspect="1"/>
+          </p:cNvPicPr>
+          <p:nvPr/>
+        </p:nvPicPr>
+        <p:blipFill>
+          <a:blip r:embed="rId2"/>
+          <a:stretch>
+            <a:fillRect/>
+          </a:stretch>
+        </p:blipFill>
+        <p:spPr>
+          <a:xfrm>
+            <a:off x="594360" y="2743200"/>
+            <a:ext cx="365760" cy="365760"/>
+          </a:xfrm>
+          <a:prstGeom prst="rect">
+            <a:avLst/>
+          </a:prstGeom>
+        </p:spPr>
+      </p:pic>
+      <p:sp>
+        <p:nvSpPr>
+          <p:cNvPr id="7" name="Text 3"/>
+          <p:cNvSpPr txBox="1"/>
+          <p:nvPr/>
+        </p:nvSpPr>
+        <p:spPr>
+          <a:xfrm>
+            <a:off x="1097280" y="2715768"/>
+            <a:ext cx="4846320" cy="594360"/>
+          </a:xfrm>
+          <a:prstGeom prst="rect">
+            <a:avLst/>
+          </a:prstGeom>
+          <a:noFill/>
+          <a:ln/>
+        </p:spPr>
+        <p:txBody>
+          <a:bodyPr wrap="square" lIns="0" tIns="0" rIns="0" bIns="0" rtlCol="0" anchor="ctr"/>
+          <a:lstStyle/>
+          <a:p>
+            <a:pPr indent="0" marL="0">
+              <a:buNone/>
+            </a:pPr>
+            <a:r>
+              <a:rPr lang="en-US" sz="1150" dirty="0">
+                <a:solidFill>
+                  <a:srgbClr val="5B6B60"/>
+                </a:solidFill>
+                <a:latin typeface="Calibri" pitchFamily="34" charset="0"/>
+                <a:ea typeface="Calibri" pitchFamily="34" charset="-122"/>
+                <a:cs typeface="Calibri" pitchFamily="34" charset="-120"/>
+              </a:rPr>
+              <a:t>Community-contributed modules: flood monitoring, temple water tanks, school environmental clubs</a:t>
+            </a:r>
+            <a:endParaRPr lang="en-US" sz="1150" dirty="0"/>
+          </a:p>
+        </p:txBody>
+      </p:sp>
+      <p:pic>
+        <p:nvPicPr>
+          <p:cNvPr id="8" name="Image 2" descr="preencoded.png">    </p:cNvPr>
+          <p:cNvPicPr>
+            <a:picLocks noChangeAspect="1"/>
+          </p:cNvPicPr>
+          <p:nvPr/>
+        </p:nvPicPr>
+        <p:blipFill>
+          <a:blip r:embed="rId3"/>
+          <a:stretch>
+            <a:fillRect/>
+          </a:stretch>
+        </p:blipFill>
+        <p:spPr>
+          <a:xfrm>
+            <a:off x="594360" y="3520440"/>
+            <a:ext cx="365760" cy="365760"/>
+          </a:xfrm>
+          <a:prstGeom prst="rect">
+            <a:avLst/>
+          </a:prstGeom>
+        </p:spPr>
+      </p:pic>
+      <p:sp>
+        <p:nvSpPr>
+          <p:cNvPr id="9" name="Text 4"/>
+          <p:cNvSpPr txBox="1"/>
+          <p:nvPr/>
+        </p:nvSpPr>
+        <p:spPr>
+          <a:xfrm>
+            <a:off x="1097280" y="3493008"/>
+            <a:ext cx="4846320" cy="594360"/>
+          </a:xfrm>
+          <a:prstGeom prst="rect">
+            <a:avLst/>
+          </a:prstGeom>
+          <a:noFill/>
+          <a:ln/>
+        </p:spPr>
+        <p:txBody>
+          <a:bodyPr wrap="square" lIns="0" tIns="0" rIns="0" bIns="0" rtlCol="0" anchor="ctr"/>
+          <a:lstStyle/>
+          <a:p>
+            <a:pPr indent="0" marL="0">
+              <a:buNone/>
+            </a:pPr>
+            <a:r>
+              <a:rPr lang="en-US" sz="1150" dirty="0">
+                <a:solidFill>
+                  <a:srgbClr val="5B6B60"/>
+                </a:solidFill>
+                <a:latin typeface="Calibri" pitchFamily="34" charset="0"/>
+                <a:ea typeface="Calibri" pitchFamily="34" charset="-122"/>
+                <a:cs typeface="Calibri" pitchFamily="34" charset="-120"/>
+              </a:rPr>
+              <a:t>Fine-tuned, domain-specific vision model to replace the auxiliary ImageNet signal</a:t>
+            </a:r>
+            <a:endParaRPr lang="en-US" sz="1150" dirty="0"/>
+          </a:p>
+        </p:txBody>
+      </p:sp>
+      <p:pic>
+        <p:nvPicPr>
+          <p:cNvPr id="10" name="Image 3" descr="preencoded.png">    </p:cNvPr>
+          <p:cNvPicPr>
+            <a:picLocks noChangeAspect="1"/>
+          </p:cNvPicPr>
+          <p:nvPr/>
+        </p:nvPicPr>
+        <p:blipFill>
+          <a:blip r:embed="rId4"/>
+          <a:stretch>
+            <a:fillRect/>
+          </a:stretch>
+        </p:blipFill>
+        <p:spPr>
+          <a:xfrm>
+            <a:off x="594360" y="4297680"/>
+            <a:ext cx="365760" cy="365760"/>
+          </a:xfrm>
+          <a:prstGeom prst="rect">
+            <a:avLst/>
+          </a:prstGeom>
+        </p:spPr>
+      </p:pic>
+      <p:sp>
+        <p:nvSpPr>
+          <p:cNvPr id="11" name="Text 5"/>
+          <p:cNvSpPr txBox="1"/>
+          <p:nvPr/>
+        </p:nvSpPr>
+        <p:spPr>
+          <a:xfrm>
+            <a:off x="1097280" y="4270248"/>
+            <a:ext cx="4846320" cy="594360"/>
+          </a:xfrm>
+          <a:prstGeom prst="rect">
+            <a:avLst/>
+          </a:prstGeom>
+          <a:noFill/>
+          <a:ln/>
+        </p:spPr>
+        <p:txBody>
+          <a:bodyPr wrap="square" lIns="0" tIns="0" rIns="0" bIns="0" rtlCol="0" anchor="ctr"/>
+          <a:lstStyle/>
+          <a:p>
+            <a:pPr indent="0" marL="0">
+              <a:buNone/>
+            </a:pPr>
+            <a:r>
+              <a:rPr lang="en-US" sz="1150" dirty="0">
+                <a:solidFill>
+                  <a:srgbClr val="5B6B60"/>
+                </a:solidFill>
+                <a:latin typeface="Calibri" pitchFamily="34" charset="0"/>
+                <a:ea typeface="Calibri" pitchFamily="34" charset="-122"/>
+                <a:cs typeface="Calibri" pitchFamily="34" charset="-120"/>
+              </a:rPr>
+              <a:t>Multi-district configuration -- Tirunelveli as the reference deployment, not the ceiling</a:t>
+            </a:r>
+            <a:endParaRPr lang="en-US" sz="1150" dirty="0"/>
+          </a:p>
+        </p:txBody>
+      </p:sp>
+      <p:sp>
+        <p:nvSpPr>
+          <p:cNvPr id="12" name="Shape 6"/>
+          <p:cNvSpPr/>
+          <p:nvPr/>
+        </p:nvSpPr>
+        <p:spPr>
+          <a:xfrm>
+            <a:off x="6309360" y="1554480"/>
+            <a:ext cx="5349240" cy="4297680"/>
+          </a:xfrm>
+          <a:prstGeom prst="roundRect">
+            <a:avLst>
+              <a:gd name="adj" fmla="val 2553"/>
+            </a:avLst>
+          </a:prstGeom>
+          <a:solidFill>
+            <a:srgbClr val="135C39"/>
+          </a:solidFill>
+          <a:ln/>
+        </p:spPr>
+      </p:sp>
+      <p:pic>
+        <p:nvPicPr>
+          <p:cNvPr id="13" name="Image 4" descr="preencoded.png">    </p:cNvPr>
+          <p:cNvPicPr>
+            <a:picLocks noChangeAspect="1"/>
+          </p:cNvPicPr>
+          <p:nvPr/>
+        </p:nvPicPr>
+        <p:blipFill>
+          <a:blip r:embed="rId5"/>
+          <a:stretch>
+            <a:fillRect/>
+          </a:stretch>
+        </p:blipFill>
+        <p:spPr>
+          <a:xfrm>
             <a:off x="6583680" y="1783080"/>
             <a:ext cx="594360" cy="594360"/>
           </a:xfrm>
@@ -9329,7 +10368,7 @@
                 <a:ea typeface="Calibri" pitchFamily="34" charset="-122"/>
                 <a:cs typeface="Calibri" pitchFamily="34" charset="-120"/>
               </a:rPr>
-              <a:t>16</a:t>
+              <a:t>17</a:t>
             </a:r>
             <a:endParaRPr lang="en-US" sz="1000" dirty="0"/>
           </a:p>

</xml_diff>